<commit_message>
docs: actualizar documentacion tecnica, diapositivas y roles de equipo para Fabian Mora, Agustin Cañas y Paul Ferrada
</commit_message>
<xml_diff>
--- a/Presentacion_AURA_SmartParking_Azure.pptx
+++ b/Presentacion_AURA_SmartParking_Azure.pptx
@@ -511,7 +511,7 @@
           <a:p>
             <a:r>
               <a:rPr lang="en-US" dirty="0"/>
-              <a:t>MINUTO 0:00 - Saludo inicial a la comisión evaluadora de Santo Tomás. Presentación del equipo de 4 integrantes y declaración de objetivos del proyecto AURA Smart Parking, articulando Arquitectura de Sistemas y Programación en la Nube.</a:t>
+              <a:t>MINUTO 0:00 - Saludo inicial a la comisión evaluadora de Santo Tomás. Presentación del equipo de 3 integrantes (Fabián Mora, Agustín Cañas, Paul Ferrada) y declaración de objetivos del proyecto AURA Smart Parking, articulando Arquitectura de Sistemas y Programación en la Nube.</a:t>
             </a:r>
             <a:endParaRPr lang="en-US" dirty="0"/>
           </a:p>
@@ -1303,7 +1303,7 @@
           <a:p>
             <a:r>
               <a:rPr lang="en-US" dirty="0"/>
-              <a:t>MINUTOS 10:00 A 13:00 - Cada integrante expone su rol y demuestra conocimiento transversal de la solución completa para obtener los 5 puntos de participación individual de la rúbrica.</a:t>
+              <a:t>MINUTOS 10:00 A 13:00 - Cada integrante (Fabián Mora, Agustín Cañas, Paul Ferrada) expone su rol y demuestra conocimiento transversal de la solución completa para obtener los 5 puntos de participación individual de la rúbrica.</a:t>
             </a:r>
             <a:endParaRPr lang="en-US" dirty="0"/>
           </a:p>
@@ -2236,7 +2236,7 @@
                 <a:ea typeface="Segoe UI" pitchFamily="34" charset="-122"/>
                 <a:cs typeface="Segoe UI" pitchFamily="34" charset="-120"/>
               </a:rPr>
-              <a:t>4 Integrantes Clave</a:t>
+              <a:t>3 Integrantes</a:t>
             </a:r>
             <a:endParaRPr lang="en-US" sz="1500" dirty="0"/>
           </a:p>
@@ -2275,7 +2275,7 @@
                 <a:ea typeface="Segoe UI" pitchFamily="34" charset="-122"/>
                 <a:cs typeface="Segoe UI" pitchFamily="34" charset="-120"/>
               </a:rPr>
-              <a:t>Integrante 1: </a:t>
+              <a:t>Fabián Mora: </a:t>
             </a:r>
             <a:pPr indent="0" marL="0">
               <a:buNone/>
@@ -2304,7 +2304,7 @@
                 <a:ea typeface="Segoe UI" pitchFamily="34" charset="-122"/>
                 <a:cs typeface="Segoe UI" pitchFamily="34" charset="-120"/>
               </a:rPr>
-              <a:t>Integrante 2: </a:t>
+              <a:t>Agustín Cañas: </a:t>
             </a:r>
             <a:pPr indent="0" marL="0">
               <a:buNone/>
@@ -2318,7 +2318,7 @@
                 <a:ea typeface="Segoe UI" pitchFamily="34" charset="-122"/>
                 <a:cs typeface="Segoe UI" pitchFamily="34" charset="-120"/>
               </a:rPr>
-              <a:t>Arquitectura &amp; API REST
+              <a:t>Arquitectura &amp; Lógica
 </a:t>
             </a:r>
             <a:pPr indent="0" marL="0">
@@ -2333,7 +2333,7 @@
                 <a:ea typeface="Segoe UI" pitchFamily="34" charset="-122"/>
                 <a:cs typeface="Segoe UI" pitchFamily="34" charset="-120"/>
               </a:rPr>
-              <a:t>Integrante 3: </a:t>
+              <a:t>Paul Ferrada: </a:t>
             </a:r>
             <a:pPr indent="0" marL="0">
               <a:buNone/>
@@ -2347,7 +2347,7 @@
                 <a:ea typeface="Segoe UI" pitchFamily="34" charset="-122"/>
                 <a:cs typeface="Segoe UI" pitchFamily="34" charset="-120"/>
               </a:rPr>
-              <a:t>Hardware &amp; IoT (Arduino)
+              <a:t>Cloud &amp; Datos (Azure)
 </a:t>
             </a:r>
             <a:pPr indent="0" marL="0">
@@ -2362,7 +2362,7 @@
                 <a:ea typeface="Segoe UI" pitchFamily="34" charset="-122"/>
                 <a:cs typeface="Segoe UI" pitchFamily="34" charset="-120"/>
               </a:rPr>
-              <a:t>Integrante 4: </a:t>
+              <a:t>Institución: </a:t>
             </a:r>
             <a:pPr indent="0" marL="0">
               <a:buNone/>
@@ -2376,7 +2376,7 @@
                 <a:ea typeface="Segoe UI" pitchFamily="34" charset="-122"/>
                 <a:cs typeface="Segoe UI" pitchFamily="34" charset="-120"/>
               </a:rPr>
-              <a:t>Cloud &amp; DevOps (Azure)
+              <a:t>IP Santo Tomás
 </a:t>
             </a:r>
             <a:endParaRPr lang="en-US" sz="1050" dirty="0"/>
@@ -2591,7 +2591,7 @@
                 <a:ea typeface="Segoe UI" pitchFamily="34" charset="-122"/>
                 <a:cs typeface="Segoe UI" pitchFamily="34" charset="-120"/>
               </a:rPr>
-              <a:t>aurasmartparking.eastus...
+              <a:t>puntoalerce.chilecentral...
 </a:t>
             </a:r>
             <a:pPr indent="0" marL="0">
@@ -2620,7 +2620,7 @@
                 <a:ea typeface="Segoe UI" pitchFamily="34" charset="-122"/>
                 <a:cs typeface="Segoe UI" pitchFamily="34" charset="-120"/>
               </a:rPr>
-              <a:t>IIS 10.0 + ARR Proxy
+              <a:t>IIS 10.0 + Web Static
 </a:t>
             </a:r>
             <a:pPr indent="0" marL="0">
@@ -3258,7 +3258,7 @@
                 <a:ea typeface="Segoe UI" pitchFamily="34" charset="-122"/>
                 <a:cs typeface="Segoe UI" pitchFamily="34" charset="-120"/>
               </a:rPr>
-              <a:t>Control de versiones con commits en español, articulando el trabajo de los 4 integrantes de forma ordenada.</a:t>
+              <a:t>Control de versiones con commits en español, articulando el trabajo de los 3 integrantes de forma ordenada.</a:t>
             </a:r>
             <a:endParaRPr lang="en-US" sz="1150" dirty="0"/>
           </a:p>
@@ -3474,7 +3474,7 @@
                 <a:ea typeface="Segoe UI" pitchFamily="34" charset="-122"/>
                 <a:cs typeface="Segoe UI" pitchFamily="34" charset="-120"/>
               </a:rPr>
-              <a:t>http://aurasmartparking.eastus.cloudapp.azure.com
+              <a:t>http://puntoalerce.chilecentral.cloudapp.azure.com
 </a:t>
             </a:r>
             <a:pPr indent="0" marL="0">
@@ -10419,7 +10419,7 @@
                 <a:ea typeface="Segoe UI" pitchFamily="34" charset="-122"/>
                 <a:cs typeface="Segoe UI" pitchFamily="34" charset="-120"/>
               </a:rPr>
-              <a:t>aurasmartparking.eastus.cloudapp.azure.com
+              <a:t>puntoalerce.chilecentral.cloudapp.azure.com
 </a:t>
             </a:r>
             <a:pPr indent="0" marL="0">
@@ -10448,7 +10448,7 @@
                 <a:ea typeface="Segoe UI" pitchFamily="34" charset="-122"/>
                 <a:cs typeface="Segoe UI" pitchFamily="34" charset="-120"/>
               </a:rPr>
-              <a:t>20.124.68.142 (Estática asignada)
+              <a:t>68.211.136.184 (Chile Central)
 </a:t>
             </a:r>
             <a:pPr indent="0" marL="0">
@@ -10477,7 +10477,7 @@
                 <a:ea typeface="Segoe UI" pitchFamily="34" charset="-122"/>
                 <a:cs typeface="Segoe UI" pitchFamily="34" charset="-120"/>
               </a:rPr>
-              <a:t>180 ms desde redes externas en Chile
+              <a:t>&lt; 50 ms desde redes locales en Chile
 </a:t>
             </a:r>
             <a:pPr indent="0" marL="0">
@@ -11907,11 +11907,11 @@
         <p:spPr>
           <a:xfrm>
             <a:off x="822960" y="1783080"/>
-            <a:ext cx="2468880" cy="4343400"/>
+            <a:ext cx="3337560" cy="4343400"/>
           </a:xfrm>
           <a:prstGeom prst="roundRect">
             <a:avLst>
-              <a:gd name="adj" fmla="val 5556"/>
+              <a:gd name="adj" fmla="val 4110"/>
             </a:avLst>
           </a:prstGeom>
           <a:solidFill>
@@ -11933,8 +11933,8 @@
         </p:nvSpPr>
         <p:spPr>
           <a:xfrm>
-            <a:off x="1005840" y="2011680"/>
-            <a:ext cx="2103120" cy="256032"/>
+            <a:off x="1051560" y="2011680"/>
+            <a:ext cx="2880360" cy="256032"/>
           </a:xfrm>
           <a:prstGeom prst="roundRect">
             <a:avLst>
@@ -11960,8 +11960,8 @@
         </p:nvSpPr>
         <p:spPr>
           <a:xfrm>
-            <a:off x="1005840" y="2011680"/>
-            <a:ext cx="2103120" cy="256032"/>
+            <a:off x="1051560" y="2011680"/>
+            <a:ext cx="2880360" cy="256032"/>
           </a:xfrm>
           <a:prstGeom prst="rect">
             <a:avLst/>
@@ -11985,7 +11985,7 @@
                 <a:ea typeface="Segoe UI" pitchFamily="34" charset="-122"/>
                 <a:cs typeface="Segoe UI" pitchFamily="34" charset="-120"/>
               </a:rPr>
-              <a:t>INTEGRANTE 1</a:t>
+              <a:t>FABIÁN MORA</a:t>
             </a:r>
             <a:endParaRPr lang="en-US" sz="850" dirty="0"/>
           </a:p>
@@ -11999,8 +11999,8 @@
         </p:nvSpPr>
         <p:spPr>
           <a:xfrm>
-            <a:off x="1005840" y="2377440"/>
-            <a:ext cx="2103120" cy="502920"/>
+            <a:off x="1051560" y="2377440"/>
+            <a:ext cx="2880360" cy="502920"/>
           </a:xfrm>
           <a:prstGeom prst="rect">
             <a:avLst/>
@@ -12038,8 +12038,8 @@
         </p:nvSpPr>
         <p:spPr>
           <a:xfrm>
-            <a:off x="1005840" y="2971800"/>
-            <a:ext cx="2103120" cy="2926080"/>
+            <a:off x="1051560" y="2971800"/>
+            <a:ext cx="2880360" cy="2926080"/>
           </a:xfrm>
           <a:prstGeom prst="rect">
             <a:avLst/>
@@ -12055,7 +12055,7 @@
               <a:buNone/>
             </a:pPr>
             <a:r>
-              <a:rPr lang="en-US" sz="920" dirty="0">
+              <a:rPr lang="en-US" sz="960" dirty="0">
                 <a:solidFill>
                   <a:srgbClr val="8E8E93"/>
                 </a:solidFill>
@@ -12070,7 +12070,7 @@
               <a:buNone/>
             </a:pPr>
             <a:r>
-              <a:rPr lang="en-US" sz="920" dirty="0">
+              <a:rPr lang="en-US" sz="960" dirty="0">
                 <a:solidFill>
                   <a:srgbClr val="8E8E93"/>
                 </a:solidFill>
@@ -12085,7 +12085,7 @@
               <a:buNone/>
             </a:pPr>
             <a:r>
-              <a:rPr lang="en-US" sz="920" dirty="0">
+              <a:rPr lang="en-US" sz="960" dirty="0">
                 <a:solidFill>
                   <a:srgbClr val="8E8E93"/>
                 </a:solidFill>
@@ -12100,7 +12100,7 @@
               <a:buNone/>
             </a:pPr>
             <a:r>
-              <a:rPr lang="en-US" sz="920" dirty="0">
+              <a:rPr lang="en-US" sz="960" dirty="0">
                 <a:solidFill>
                   <a:srgbClr val="8E8E93"/>
                 </a:solidFill>
@@ -12115,7 +12115,7 @@
               <a:buNone/>
             </a:pPr>
             <a:r>
-              <a:rPr lang="en-US" sz="920" dirty="0">
+              <a:rPr lang="en-US" sz="960" dirty="0">
                 <a:solidFill>
                   <a:srgbClr val="8E8E93"/>
                 </a:solidFill>
@@ -12126,7 +12126,7 @@
               <a:t>• Generación de Pase Digital QR y feedback sonoro.
 </a:t>
             </a:r>
-            <a:endParaRPr lang="en-US" sz="920" dirty="0"/>
+            <a:endParaRPr lang="en-US" sz="960" dirty="0"/>
           </a:p>
         </p:txBody>
       </p:sp>
@@ -12138,12 +12138,12 @@
         </p:nvSpPr>
         <p:spPr>
           <a:xfrm>
-            <a:off x="3511296" y="1783080"/>
-            <a:ext cx="2468880" cy="4343400"/>
+            <a:off x="4425696" y="1783080"/>
+            <a:ext cx="3337560" cy="4343400"/>
           </a:xfrm>
           <a:prstGeom prst="roundRect">
             <a:avLst>
-              <a:gd name="adj" fmla="val 5556"/>
+              <a:gd name="adj" fmla="val 4110"/>
             </a:avLst>
           </a:prstGeom>
           <a:solidFill>
@@ -12165,8 +12165,8 @@
         </p:nvSpPr>
         <p:spPr>
           <a:xfrm>
-            <a:off x="3694176" y="2011680"/>
-            <a:ext cx="2103120" cy="256032"/>
+            <a:off x="4654296" y="2011680"/>
+            <a:ext cx="2880360" cy="256032"/>
           </a:xfrm>
           <a:prstGeom prst="roundRect">
             <a:avLst>
@@ -12192,8 +12192,8 @@
         </p:nvSpPr>
         <p:spPr>
           <a:xfrm>
-            <a:off x="3694176" y="2011680"/>
-            <a:ext cx="2103120" cy="256032"/>
+            <a:off x="4654296" y="2011680"/>
+            <a:ext cx="2880360" cy="256032"/>
           </a:xfrm>
           <a:prstGeom prst="rect">
             <a:avLst/>
@@ -12217,7 +12217,7 @@
                 <a:ea typeface="Segoe UI" pitchFamily="34" charset="-122"/>
                 <a:cs typeface="Segoe UI" pitchFamily="34" charset="-120"/>
               </a:rPr>
-              <a:t>INTEGRANTE 2</a:t>
+              <a:t>AGUSTÍN CAÑAS</a:t>
             </a:r>
             <a:endParaRPr lang="en-US" sz="850" dirty="0"/>
           </a:p>
@@ -12231,8 +12231,8 @@
         </p:nvSpPr>
         <p:spPr>
           <a:xfrm>
-            <a:off x="3694176" y="2377440"/>
-            <a:ext cx="2103120" cy="502920"/>
+            <a:off x="4654296" y="2377440"/>
+            <a:ext cx="2880360" cy="502920"/>
           </a:xfrm>
           <a:prstGeom prst="rect">
             <a:avLst/>
@@ -12256,7 +12256,7 @@
                 <a:ea typeface="Segoe UI" pitchFamily="34" charset="-122"/>
                 <a:cs typeface="Segoe UI" pitchFamily="34" charset="-120"/>
               </a:rPr>
-              <a:t>Arquitectura &amp; Backend</a:t>
+              <a:t>Arquitectura &amp; Lógica de Negocio</a:t>
             </a:r>
             <a:endParaRPr lang="en-US" sz="1200" dirty="0"/>
           </a:p>
@@ -12270,8 +12270,8 @@
         </p:nvSpPr>
         <p:spPr>
           <a:xfrm>
-            <a:off x="3694176" y="2971800"/>
-            <a:ext cx="2103120" cy="2926080"/>
+            <a:off x="4654296" y="2971800"/>
+            <a:ext cx="2880360" cy="2926080"/>
           </a:xfrm>
           <a:prstGeom prst="rect">
             <a:avLst/>
@@ -12287,7 +12287,7 @@
               <a:buNone/>
             </a:pPr>
             <a:r>
-              <a:rPr lang="en-US" sz="920" dirty="0">
+              <a:rPr lang="en-US" sz="960" dirty="0">
                 <a:solidFill>
                   <a:srgbClr val="8E8E93"/>
                 </a:solidFill>
@@ -12295,14 +12295,14 @@
                 <a:ea typeface="Segoe UI" pitchFamily="34" charset="-122"/>
                 <a:cs typeface="Segoe UI" pitchFamily="34" charset="-120"/>
               </a:rPr>
-              <a:t>• Definición del modelo desacoplado en 4 capas.
+              <a:t>• Definición del modelo desacoplado en 4 capas de software.
 </a:t>
             </a:r>
             <a:pPr indent="0" marL="0">
               <a:buNone/>
             </a:pPr>
             <a:r>
-              <a:rPr lang="en-US" sz="920" dirty="0">
+              <a:rPr lang="en-US" sz="960" dirty="0">
                 <a:solidFill>
                   <a:srgbClr val="8E8E93"/>
                 </a:solidFill>
@@ -12310,14 +12310,14 @@
                 <a:ea typeface="Segoe UI" pitchFamily="34" charset="-122"/>
                 <a:cs typeface="Segoe UI" pitchFamily="34" charset="-120"/>
               </a:rPr>
-              <a:t>• Controladores RESTful en Node.js y Express.
+              <a:t>• Orquestación de estados: Disponible, Reservado y Ocupado.
 </a:t>
             </a:r>
             <a:pPr indent="0" marL="0">
               <a:buNone/>
             </a:pPr>
             <a:r>
-              <a:rPr lang="en-US" sz="920" dirty="0">
+              <a:rPr lang="en-US" sz="960" dirty="0">
                 <a:solidFill>
                   <a:srgbClr val="8E8E93"/>
                 </a:solidFill>
@@ -12325,14 +12325,14 @@
                 <a:ea typeface="Segoe UI" pitchFamily="34" charset="-122"/>
                 <a:cs typeface="Segoe UI" pitchFamily="34" charset="-120"/>
               </a:rPr>
-              <a:t>• Motor de reglas de negocio y tarificación ($35/min).
+              <a:t>• Algoritmo de tarificación automatizada por minuto ($35 CLP/min).
 </a:t>
             </a:r>
             <a:pPr indent="0" marL="0">
               <a:buNone/>
             </a:pPr>
             <a:r>
-              <a:rPr lang="en-US" sz="920" dirty="0">
+              <a:rPr lang="en-US" sz="960" dirty="0">
                 <a:solidFill>
                   <a:srgbClr val="8E8E93"/>
                 </a:solidFill>
@@ -12340,14 +12340,14 @@
                 <a:ea typeface="Segoe UI" pitchFamily="34" charset="-122"/>
                 <a:cs typeface="Segoe UI" pitchFamily="34" charset="-120"/>
               </a:rPr>
-              <a:t>• Orquestación de operaciones CRUD e integridad de datos.
+              <a:t>• Validaciones de formato chileno de patentes (BB-BB-11 / BBBB-11).
 </a:t>
             </a:r>
             <a:pPr indent="0" marL="0">
               <a:buNone/>
             </a:pPr>
             <a:r>
-              <a:rPr lang="en-US" sz="920" dirty="0">
+              <a:rPr lang="en-US" sz="960" dirty="0">
                 <a:solidFill>
                   <a:srgbClr val="8E8E93"/>
                 </a:solidFill>
@@ -12355,10 +12355,10 @@
                 <a:ea typeface="Segoe UI" pitchFamily="34" charset="-122"/>
                 <a:cs typeface="Segoe UI" pitchFamily="34" charset="-120"/>
               </a:rPr>
-              <a:t>• Manejo de excepciones HTTP y auditoría en consola.
+              <a:t>• Trazabilidad y consistencia transaccional end-to-end.
 </a:t>
             </a:r>
-            <a:endParaRPr lang="en-US" sz="920" dirty="0"/>
+            <a:endParaRPr lang="en-US" sz="960" dirty="0"/>
           </a:p>
         </p:txBody>
       </p:sp>
@@ -12370,12 +12370,12 @@
         </p:nvSpPr>
         <p:spPr>
           <a:xfrm>
-            <a:off x="6199632" y="1783080"/>
-            <a:ext cx="2468880" cy="4343400"/>
+            <a:off x="8028432" y="1783080"/>
+            <a:ext cx="3337560" cy="4343400"/>
           </a:xfrm>
           <a:prstGeom prst="roundRect">
             <a:avLst>
-              <a:gd name="adj" fmla="val 5556"/>
+              <a:gd name="adj" fmla="val 4110"/>
             </a:avLst>
           </a:prstGeom>
           <a:solidFill>
@@ -12397,240 +12397,8 @@
         </p:nvSpPr>
         <p:spPr>
           <a:xfrm>
-            <a:off x="6382512" y="2011680"/>
-            <a:ext cx="2103120" cy="256032"/>
-          </a:xfrm>
-          <a:prstGeom prst="roundRect">
-            <a:avLst>
-              <a:gd name="adj" fmla="val 50000"/>
-            </a:avLst>
-          </a:prstGeom>
-          <a:solidFill>
-            <a:srgbClr val="1C1E28"/>
-          </a:solidFill>
-          <a:ln w="10160">
-            <a:solidFill>
-              <a:srgbClr val="FF9F0A"/>
-            </a:solidFill>
-            <a:prstDash val="solid"/>
-          </a:ln>
-        </p:spPr>
-      </p:sp>
-      <p:sp>
-        <p:nvSpPr>
-          <p:cNvPr id="20" name="Text 18"/>
-          <p:cNvSpPr/>
-          <p:nvPr/>
-        </p:nvSpPr>
-        <p:spPr>
-          <a:xfrm>
-            <a:off x="6382512" y="2011680"/>
-            <a:ext cx="2103120" cy="256032"/>
-          </a:xfrm>
-          <a:prstGeom prst="rect">
-            <a:avLst/>
-          </a:prstGeom>
-          <a:noFill/>
-          <a:ln/>
-        </p:spPr>
-        <p:txBody>
-          <a:bodyPr wrap="square" rtlCol="0" anchor="ctr"/>
-          <a:lstStyle/>
-          <a:p>
-            <a:pPr algn="ctr" indent="0" marL="0">
-              <a:buNone/>
-            </a:pPr>
-            <a:r>
-              <a:rPr lang="en-US" sz="850" b="1" dirty="0">
-                <a:solidFill>
-                  <a:srgbClr val="FF9F0A"/>
-                </a:solidFill>
-                <a:latin typeface="Segoe UI" pitchFamily="34" charset="0"/>
-                <a:ea typeface="Segoe UI" pitchFamily="34" charset="-122"/>
-                <a:cs typeface="Segoe UI" pitchFamily="34" charset="-120"/>
-              </a:rPr>
-              <a:t>INTEGRANTE 3</a:t>
-            </a:r>
-            <a:endParaRPr lang="en-US" sz="850" dirty="0"/>
-          </a:p>
-        </p:txBody>
-      </p:sp>
-      <p:sp>
-        <p:nvSpPr>
-          <p:cNvPr id="21" name="Text 19"/>
-          <p:cNvSpPr/>
-          <p:nvPr/>
-        </p:nvSpPr>
-        <p:spPr>
-          <a:xfrm>
-            <a:off x="6382512" y="2377440"/>
-            <a:ext cx="2103120" cy="502920"/>
-          </a:xfrm>
-          <a:prstGeom prst="rect">
-            <a:avLst/>
-          </a:prstGeom>
-          <a:noFill/>
-          <a:ln/>
-        </p:spPr>
-        <p:txBody>
-          <a:bodyPr wrap="square" rtlCol="0" anchor="t"/>
-          <a:lstStyle/>
-          <a:p>
-            <a:pPr indent="0" marL="0">
-              <a:buNone/>
-            </a:pPr>
-            <a:r>
-              <a:rPr lang="en-US" sz="1200" b="1" dirty="0">
-                <a:solidFill>
-                  <a:srgbClr val="FFFFFF"/>
-                </a:solidFill>
-                <a:latin typeface="Segoe UI" pitchFamily="34" charset="0"/>
-                <a:ea typeface="Segoe UI" pitchFamily="34" charset="-122"/>
-                <a:cs typeface="Segoe UI" pitchFamily="34" charset="-120"/>
-              </a:rPr>
-              <a:t>Hardware &amp; IoT (Firmware)</a:t>
-            </a:r>
-            <a:endParaRPr lang="en-US" sz="1200" dirty="0"/>
-          </a:p>
-        </p:txBody>
-      </p:sp>
-      <p:sp>
-        <p:nvSpPr>
-          <p:cNvPr id="22" name="Text 20"/>
-          <p:cNvSpPr/>
-          <p:nvPr/>
-        </p:nvSpPr>
-        <p:spPr>
-          <a:xfrm>
-            <a:off x="6382512" y="2971800"/>
-            <a:ext cx="2103120" cy="2926080"/>
-          </a:xfrm>
-          <a:prstGeom prst="rect">
-            <a:avLst/>
-          </a:prstGeom>
-          <a:noFill/>
-          <a:ln/>
-        </p:spPr>
-        <p:txBody>
-          <a:bodyPr wrap="square" rtlCol="0" anchor="t"/>
-          <a:lstStyle/>
-          <a:p>
-            <a:pPr indent="0" marL="0">
-              <a:buNone/>
-            </a:pPr>
-            <a:r>
-              <a:rPr lang="en-US" sz="920" dirty="0">
-                <a:solidFill>
-                  <a:srgbClr val="8E8E93"/>
-                </a:solidFill>
-                <a:latin typeface="Segoe UI" pitchFamily="34" charset="0"/>
-                <a:ea typeface="Segoe UI" pitchFamily="34" charset="-122"/>
-                <a:cs typeface="Segoe UI" pitchFamily="34" charset="-120"/>
-              </a:rPr>
-              <a:t>• Programación C++ embebida en Arduino UNO R3.
-</a:t>
-            </a:r>
-            <a:pPr indent="0" marL="0">
-              <a:buNone/>
-            </a:pPr>
-            <a:r>
-              <a:rPr lang="en-US" sz="920" dirty="0">
-                <a:solidFill>
-                  <a:srgbClr val="8E8E93"/>
-                </a:solidFill>
-                <a:latin typeface="Segoe UI" pitchFamily="34" charset="0"/>
-                <a:ea typeface="Segoe UI" pitchFamily="34" charset="-122"/>
-                <a:cs typeface="Segoe UI" pitchFamily="34" charset="-120"/>
-              </a:rPr>
-              <a:t>• Matriz de 8 sensores ultrasónicos HC-SR04.
-</a:t>
-            </a:r>
-            <a:pPr indent="0" marL="0">
-              <a:buNone/>
-            </a:pPr>
-            <a:r>
-              <a:rPr lang="en-US" sz="920" dirty="0">
-                <a:solidFill>
-                  <a:srgbClr val="8E8E93"/>
-                </a:solidFill>
-                <a:latin typeface="Segoe UI" pitchFamily="34" charset="0"/>
-                <a:ea typeface="Segoe UI" pitchFamily="34" charset="-122"/>
-                <a:cs typeface="Segoe UI" pitchFamily="34" charset="-120"/>
-              </a:rPr>
-              <a:t>• Técnica de disparo compartido en Pin 2 Trigger.
-</a:t>
-            </a:r>
-            <a:pPr indent="0" marL="0">
-              <a:buNone/>
-            </a:pPr>
-            <a:r>
-              <a:rPr lang="en-US" sz="920" dirty="0">
-                <a:solidFill>
-                  <a:srgbClr val="8E8E93"/>
-                </a:solidFill>
-                <a:latin typeface="Segoe UI" pitchFamily="34" charset="0"/>
-                <a:ea typeface="Segoe UI" pitchFamily="34" charset="-122"/>
-                <a:cs typeface="Segoe UI" pitchFamily="34" charset="-120"/>
-              </a:rPr>
-              <a:t>• Control de 2 servomotores SG90 y display LCD 16x2.
-</a:t>
-            </a:r>
-            <a:pPr indent="0" marL="0">
-              <a:buNone/>
-            </a:pPr>
-            <a:r>
-              <a:rPr lang="en-US" sz="920" dirty="0">
-                <a:solidFill>
-                  <a:srgbClr val="8E8E93"/>
-                </a:solidFill>
-                <a:latin typeface="Segoe UI" pitchFamily="34" charset="0"/>
-                <a:ea typeface="Segoe UI" pitchFamily="34" charset="-122"/>
-                <a:cs typeface="Segoe UI" pitchFamily="34" charset="-120"/>
-              </a:rPr>
-              <a:t>• Enlace bidireccional Web Serial API a 115200 baudios.
-</a:t>
-            </a:r>
-            <a:endParaRPr lang="en-US" sz="920" dirty="0"/>
-          </a:p>
-        </p:txBody>
-      </p:sp>
-      <p:sp>
-        <p:nvSpPr>
-          <p:cNvPr id="23" name="Shape 21"/>
-          <p:cNvSpPr/>
-          <p:nvPr/>
-        </p:nvSpPr>
-        <p:spPr>
-          <a:xfrm>
-            <a:off x="8887968" y="1783080"/>
-            <a:ext cx="2468880" cy="4343400"/>
-          </a:xfrm>
-          <a:prstGeom prst="roundRect">
-            <a:avLst>
-              <a:gd name="adj" fmla="val 5556"/>
-            </a:avLst>
-          </a:prstGeom>
-          <a:solidFill>
-            <a:srgbClr val="14151B"/>
-          </a:solidFill>
-          <a:ln w="12700">
-            <a:solidFill>
-              <a:srgbClr val="242630"/>
-            </a:solidFill>
-            <a:prstDash val="solid"/>
-          </a:ln>
-        </p:spPr>
-      </p:sp>
-      <p:sp>
-        <p:nvSpPr>
-          <p:cNvPr id="24" name="Shape 22"/>
-          <p:cNvSpPr/>
-          <p:nvPr/>
-        </p:nvSpPr>
-        <p:spPr>
-          <a:xfrm>
-            <a:off x="9070848" y="2011680"/>
-            <a:ext cx="2103120" cy="256032"/>
+            <a:off x="8257032" y="2011680"/>
+            <a:ext cx="2880360" cy="256032"/>
           </a:xfrm>
           <a:prstGeom prst="roundRect">
             <a:avLst>
@@ -12650,14 +12418,14 @@
       </p:sp>
       <p:sp>
         <p:nvSpPr>
-          <p:cNvPr id="25" name="Text 23"/>
-          <p:cNvSpPr/>
-          <p:nvPr/>
-        </p:nvSpPr>
-        <p:spPr>
-          <a:xfrm>
-            <a:off x="9070848" y="2011680"/>
-            <a:ext cx="2103120" cy="256032"/>
+          <p:cNvPr id="20" name="Text 18"/>
+          <p:cNvSpPr/>
+          <p:nvPr/>
+        </p:nvSpPr>
+        <p:spPr>
+          <a:xfrm>
+            <a:off x="8257032" y="2011680"/>
+            <a:ext cx="2880360" cy="256032"/>
           </a:xfrm>
           <a:prstGeom prst="rect">
             <a:avLst/>
@@ -12681,7 +12449,7 @@
                 <a:ea typeface="Segoe UI" pitchFamily="34" charset="-122"/>
                 <a:cs typeface="Segoe UI" pitchFamily="34" charset="-120"/>
               </a:rPr>
-              <a:t>INTEGRANTE 4</a:t>
+              <a:t>PAUL FERRADA</a:t>
             </a:r>
             <a:endParaRPr lang="en-US" sz="850" dirty="0"/>
           </a:p>
@@ -12689,14 +12457,14 @@
       </p:sp>
       <p:sp>
         <p:nvSpPr>
-          <p:cNvPr id="26" name="Text 24"/>
-          <p:cNvSpPr/>
-          <p:nvPr/>
-        </p:nvSpPr>
-        <p:spPr>
-          <a:xfrm>
-            <a:off x="9070848" y="2377440"/>
-            <a:ext cx="2103120" cy="502920"/>
+          <p:cNvPr id="21" name="Text 19"/>
+          <p:cNvSpPr/>
+          <p:nvPr/>
+        </p:nvSpPr>
+        <p:spPr>
+          <a:xfrm>
+            <a:off x="8257032" y="2377440"/>
+            <a:ext cx="2880360" cy="502920"/>
           </a:xfrm>
           <a:prstGeom prst="rect">
             <a:avLst/>
@@ -12720,7 +12488,7 @@
                 <a:ea typeface="Segoe UI" pitchFamily="34" charset="-122"/>
                 <a:cs typeface="Segoe UI" pitchFamily="34" charset="-120"/>
               </a:rPr>
-              <a:t>Cloud &amp; DevOps (Azure)</a:t>
+              <a:t>Datos Cloud, DevOps &amp; Azure</a:t>
             </a:r>
             <a:endParaRPr lang="en-US" sz="1200" dirty="0"/>
           </a:p>
@@ -12728,14 +12496,14 @@
       </p:sp>
       <p:sp>
         <p:nvSpPr>
-          <p:cNvPr id="27" name="Text 25"/>
-          <p:cNvSpPr/>
-          <p:nvPr/>
-        </p:nvSpPr>
-        <p:spPr>
-          <a:xfrm>
-            <a:off x="9070848" y="2971800"/>
-            <a:ext cx="2103120" cy="2926080"/>
+          <p:cNvPr id="22" name="Text 20"/>
+          <p:cNvSpPr/>
+          <p:nvPr/>
+        </p:nvSpPr>
+        <p:spPr>
+          <a:xfrm>
+            <a:off x="8257032" y="2971800"/>
+            <a:ext cx="2880360" cy="2926080"/>
           </a:xfrm>
           <a:prstGeom prst="rect">
             <a:avLst/>
@@ -12751,7 +12519,7 @@
               <a:buNone/>
             </a:pPr>
             <a:r>
-              <a:rPr lang="en-US" sz="920" dirty="0">
+              <a:rPr lang="en-US" sz="960" dirty="0">
                 <a:solidFill>
                   <a:srgbClr val="8E8E93"/>
                 </a:solidFill>
@@ -12759,14 +12527,14 @@
                 <a:ea typeface="Segoe UI" pitchFamily="34" charset="-122"/>
                 <a:cs typeface="Segoe UI" pitchFamily="34" charset="-120"/>
               </a:rPr>
-              <a:t>• Aprovisionamiento de VM en Microsoft Azure.
+              <a:t>• Aprovisionamiento de VM en Microsoft Azure (Chile Central).
 </a:t>
             </a:r>
             <a:pPr indent="0" marL="0">
               <a:buNone/>
             </a:pPr>
             <a:r>
-              <a:rPr lang="en-US" sz="920" dirty="0">
+              <a:rPr lang="en-US" sz="960" dirty="0">
                 <a:solidFill>
                   <a:srgbClr val="8E8E93"/>
                 </a:solidFill>
@@ -12774,14 +12542,14 @@
                 <a:ea typeface="Segoe UI" pitchFamily="34" charset="-122"/>
                 <a:cs typeface="Segoe UI" pitchFamily="34" charset="-120"/>
               </a:rPr>
-              <a:t>• Endurecimiento de Windows Server 2022 Datacenter.
+              <a:t>• Endurecimiento de Windows Server 2022 con IIS 10.0.
 </a:t>
             </a:r>
             <a:pPr indent="0" marL="0">
               <a:buNone/>
             </a:pPr>
             <a:r>
-              <a:rPr lang="en-US" sz="920" dirty="0">
+              <a:rPr lang="en-US" sz="960" dirty="0">
                 <a:solidFill>
                   <a:srgbClr val="8E8E93"/>
                 </a:solidFill>
@@ -12789,14 +12557,14 @@
                 <a:ea typeface="Segoe UI" pitchFamily="34" charset="-122"/>
                 <a:cs typeface="Segoe UI" pitchFamily="34" charset="-120"/>
               </a:rPr>
-              <a:t>• Instalación y configuración de IIS con ARR Proxy.
+              <a:t>• Reglas de seguridad en NSG (Puerto 80 HTTP y 3389 RDP).
 </a:t>
             </a:r>
             <a:pPr indent="0" marL="0">
               <a:buNone/>
             </a:pPr>
             <a:r>
-              <a:rPr lang="en-US" sz="920" dirty="0">
+              <a:rPr lang="en-US" sz="960" dirty="0">
                 <a:solidFill>
                   <a:srgbClr val="8E8E93"/>
                 </a:solidFill>
@@ -12804,14 +12572,14 @@
                 <a:ea typeface="Segoe UI" pitchFamily="34" charset="-122"/>
                 <a:cs typeface="Segoe UI" pitchFamily="34" charset="-120"/>
               </a:rPr>
-              <a:t>• Reglas de firewall en NSG (Puertos 80, 443, 3001, 3389).
+              <a:t>• Configuración de Azure DNS (puntoalerce) e IP pública.
 </a:t>
             </a:r>
             <a:pPr indent="0" marL="0">
               <a:buNone/>
             </a:pPr>
             <a:r>
-              <a:rPr lang="en-US" sz="920" dirty="0">
+              <a:rPr lang="en-US" sz="960" dirty="0">
                 <a:solidFill>
                   <a:srgbClr val="8E8E93"/>
                 </a:solidFill>
@@ -12819,10 +12587,10 @@
                 <a:ea typeface="Segoe UI" pitchFamily="34" charset="-122"/>
                 <a:cs typeface="Segoe UI" pitchFamily="34" charset="-120"/>
               </a:rPr>
-              <a:t>• Configuración de Azure DNS (FQDN) y validación externa.
+              <a:t>• Integración y sincronización con Firebase Firestore (nubarda).
 </a:t>
             </a:r>
-            <a:endParaRPr lang="en-US" sz="920" dirty="0"/>
+            <a:endParaRPr lang="en-US" sz="960" dirty="0"/>
           </a:p>
         </p:txBody>
       </p:sp>

</xml_diff>

<commit_message>
docs: actualizar version final de informes, diapositivas y arquitectura para los 4 integrantes (Paul Ferrada, Agustin Cañas, Fabian Mora y Felipe Labarca)
</commit_message>
<xml_diff>
--- a/Presentacion_AURA_SmartParking_Azure.pptx
+++ b/Presentacion_AURA_SmartParking_Azure.pptx
@@ -511,7 +511,7 @@
           <a:p>
             <a:r>
               <a:rPr lang="en-US" dirty="0"/>
-              <a:t>MINUTO 0:00 - Saludo inicial a la comisión evaluadora de Santo Tomás. Presentación del equipo de 3 integrantes (Fabián Mora, Agustín Cañas, Paul Ferrada) y declaración de objetivos del proyecto AURA Smart Parking, articulando Arquitectura de Sistemas y Programación en la Nube.</a:t>
+              <a:t>MINUTO 0:00 - Saludo inicial a la comisión evaluadora de Santo Tomás. Presentación del equipo de 4 integrantes (Paul Ferrada, Agustín Cañas, Fabián Mora, Felipe Labarca) y declaración de objetivos del proyecto AURA Smart Parking, articulando Arquitectura de Sistemas y Programación en la Nube.</a:t>
             </a:r>
             <a:endParaRPr lang="en-US" dirty="0"/>
           </a:p>
@@ -1303,7 +1303,7 @@
           <a:p>
             <a:r>
               <a:rPr lang="en-US" dirty="0"/>
-              <a:t>MINUTOS 10:00 A 13:00 - Cada integrante (Fabián Mora, Agustín Cañas, Paul Ferrada) expone su rol y demuestra conocimiento transversal de la solución completa para obtener los 5 puntos de participación individual de la rúbrica.</a:t>
+              <a:t>MINUTOS 10:00 A 13:00 - Cada integrante (Paul Ferrada, Agustín Cañas, Fabián Mora, Felipe Labarca) expone su rol y demuestra conocimiento transversal de la solución completa para obtener los 5 puntos de participación individual de la rúbrica.</a:t>
             </a:r>
             <a:endParaRPr lang="en-US" dirty="0"/>
           </a:p>
@@ -2236,7 +2236,7 @@
                 <a:ea typeface="Segoe UI" pitchFamily="34" charset="-122"/>
                 <a:cs typeface="Segoe UI" pitchFamily="34" charset="-120"/>
               </a:rPr>
-              <a:t>3 Integrantes</a:t>
+              <a:t>4 Integrantes Clave</a:t>
             </a:r>
             <a:endParaRPr lang="en-US" sz="1500" dirty="0"/>
           </a:p>
@@ -2347,7 +2347,7 @@
                 <a:ea typeface="Segoe UI" pitchFamily="34" charset="-122"/>
                 <a:cs typeface="Segoe UI" pitchFamily="34" charset="-120"/>
               </a:rPr>
-              <a:t>Cloud &amp; Datos (Azure)
+              <a:t>Cloud &amp; Azure (IIS)
 </a:t>
             </a:r>
             <a:pPr indent="0" marL="0">
@@ -2362,7 +2362,7 @@
                 <a:ea typeface="Segoe UI" pitchFamily="34" charset="-122"/>
                 <a:cs typeface="Segoe UI" pitchFamily="34" charset="-120"/>
               </a:rPr>
-              <a:t>Institución: </a:t>
+              <a:t>Felipe Labarca: </a:t>
             </a:r>
             <a:pPr indent="0" marL="0">
               <a:buNone/>
@@ -2376,7 +2376,7 @@
                 <a:ea typeface="Segoe UI" pitchFamily="34" charset="-122"/>
                 <a:cs typeface="Segoe UI" pitchFamily="34" charset="-120"/>
               </a:rPr>
-              <a:t>IP Santo Tomás
+              <a:t>Seguridad JWT &amp; Firestore
 </a:t>
             </a:r>
             <a:endParaRPr lang="en-US" sz="1050" dirty="0"/>
@@ -3258,7 +3258,7 @@
                 <a:ea typeface="Segoe UI" pitchFamily="34" charset="-122"/>
                 <a:cs typeface="Segoe UI" pitchFamily="34" charset="-120"/>
               </a:rPr>
-              <a:t>Control de versiones con commits en español, articulando el trabajo de los 3 integrantes de forma ordenada.</a:t>
+              <a:t>Control de versiones con commits en español, articulando el trabajo de los 4 integrantes (Paul Ferrada, Agustín Cañas, Fabián Mora, Felipe Labarca) de forma ordenada.</a:t>
             </a:r>
             <a:endParaRPr lang="en-US" sz="1150" dirty="0"/>
           </a:p>
@@ -11907,11 +11907,11 @@
         <p:spPr>
           <a:xfrm>
             <a:off x="822960" y="1783080"/>
-            <a:ext cx="3337560" cy="4343400"/>
+            <a:ext cx="2468880" cy="4343400"/>
           </a:xfrm>
           <a:prstGeom prst="roundRect">
             <a:avLst>
-              <a:gd name="adj" fmla="val 4110"/>
+              <a:gd name="adj" fmla="val 5556"/>
             </a:avLst>
           </a:prstGeom>
           <a:solidFill>
@@ -11933,8 +11933,8 @@
         </p:nvSpPr>
         <p:spPr>
           <a:xfrm>
-            <a:off x="1051560" y="2011680"/>
-            <a:ext cx="2880360" cy="256032"/>
+            <a:off x="1005840" y="2011680"/>
+            <a:ext cx="2103120" cy="256032"/>
           </a:xfrm>
           <a:prstGeom prst="roundRect">
             <a:avLst>
@@ -11960,8 +11960,8 @@
         </p:nvSpPr>
         <p:spPr>
           <a:xfrm>
-            <a:off x="1051560" y="2011680"/>
-            <a:ext cx="2880360" cy="256032"/>
+            <a:off x="1005840" y="2011680"/>
+            <a:ext cx="2103120" cy="256032"/>
           </a:xfrm>
           <a:prstGeom prst="rect">
             <a:avLst/>
@@ -11999,8 +11999,8 @@
         </p:nvSpPr>
         <p:spPr>
           <a:xfrm>
-            <a:off x="1051560" y="2377440"/>
-            <a:ext cx="2880360" cy="502920"/>
+            <a:off x="1005840" y="2377440"/>
+            <a:ext cx="2103120" cy="502920"/>
           </a:xfrm>
           <a:prstGeom prst="rect">
             <a:avLst/>
@@ -12038,8 +12038,8 @@
         </p:nvSpPr>
         <p:spPr>
           <a:xfrm>
-            <a:off x="1051560" y="2971800"/>
-            <a:ext cx="2880360" cy="2926080"/>
+            <a:off x="1005840" y="2971800"/>
+            <a:ext cx="2103120" cy="2926080"/>
           </a:xfrm>
           <a:prstGeom prst="rect">
             <a:avLst/>
@@ -12055,7 +12055,7 @@
               <a:buNone/>
             </a:pPr>
             <a:r>
-              <a:rPr lang="en-US" sz="960" dirty="0">
+              <a:rPr lang="en-US" sz="900" dirty="0">
                 <a:solidFill>
                   <a:srgbClr val="8E8E93"/>
                 </a:solidFill>
@@ -12070,7 +12070,7 @@
               <a:buNone/>
             </a:pPr>
             <a:r>
-              <a:rPr lang="en-US" sz="960" dirty="0">
+              <a:rPr lang="en-US" sz="900" dirty="0">
                 <a:solidFill>
                   <a:srgbClr val="8E8E93"/>
                 </a:solidFill>
@@ -12085,7 +12085,7 @@
               <a:buNone/>
             </a:pPr>
             <a:r>
-              <a:rPr lang="en-US" sz="960" dirty="0">
+              <a:rPr lang="en-US" sz="900" dirty="0">
                 <a:solidFill>
                   <a:srgbClr val="8E8E93"/>
                 </a:solidFill>
@@ -12100,7 +12100,7 @@
               <a:buNone/>
             </a:pPr>
             <a:r>
-              <a:rPr lang="en-US" sz="960" dirty="0">
+              <a:rPr lang="en-US" sz="900" dirty="0">
                 <a:solidFill>
                   <a:srgbClr val="8E8E93"/>
                 </a:solidFill>
@@ -12115,7 +12115,7 @@
               <a:buNone/>
             </a:pPr>
             <a:r>
-              <a:rPr lang="en-US" sz="960" dirty="0">
+              <a:rPr lang="en-US" sz="900" dirty="0">
                 <a:solidFill>
                   <a:srgbClr val="8E8E93"/>
                 </a:solidFill>
@@ -12123,10 +12123,10 @@
                 <a:ea typeface="Segoe UI" pitchFamily="34" charset="-122"/>
                 <a:cs typeface="Segoe UI" pitchFamily="34" charset="-120"/>
               </a:rPr>
-              <a:t>• Generación de Pase Digital QR y feedback sonoro.
+              <a:t>• Generación de Pase Digital QR y feedback visual/sonoro.
 </a:t>
             </a:r>
-            <a:endParaRPr lang="en-US" sz="960" dirty="0"/>
+            <a:endParaRPr lang="en-US" sz="900" dirty="0"/>
           </a:p>
         </p:txBody>
       </p:sp>
@@ -12138,12 +12138,12 @@
         </p:nvSpPr>
         <p:spPr>
           <a:xfrm>
-            <a:off x="4425696" y="1783080"/>
-            <a:ext cx="3337560" cy="4343400"/>
+            <a:off x="3511296" y="1783080"/>
+            <a:ext cx="2468880" cy="4343400"/>
           </a:xfrm>
           <a:prstGeom prst="roundRect">
             <a:avLst>
-              <a:gd name="adj" fmla="val 4110"/>
+              <a:gd name="adj" fmla="val 5556"/>
             </a:avLst>
           </a:prstGeom>
           <a:solidFill>
@@ -12165,8 +12165,8 @@
         </p:nvSpPr>
         <p:spPr>
           <a:xfrm>
-            <a:off x="4654296" y="2011680"/>
-            <a:ext cx="2880360" cy="256032"/>
+            <a:off x="3694176" y="2011680"/>
+            <a:ext cx="2103120" cy="256032"/>
           </a:xfrm>
           <a:prstGeom prst="roundRect">
             <a:avLst>
@@ -12192,8 +12192,8 @@
         </p:nvSpPr>
         <p:spPr>
           <a:xfrm>
-            <a:off x="4654296" y="2011680"/>
-            <a:ext cx="2880360" cy="256032"/>
+            <a:off x="3694176" y="2011680"/>
+            <a:ext cx="2103120" cy="256032"/>
           </a:xfrm>
           <a:prstGeom prst="rect">
             <a:avLst/>
@@ -12231,8 +12231,8 @@
         </p:nvSpPr>
         <p:spPr>
           <a:xfrm>
-            <a:off x="4654296" y="2377440"/>
-            <a:ext cx="2880360" cy="502920"/>
+            <a:off x="3694176" y="2377440"/>
+            <a:ext cx="2103120" cy="502920"/>
           </a:xfrm>
           <a:prstGeom prst="rect">
             <a:avLst/>
@@ -12270,8 +12270,8 @@
         </p:nvSpPr>
         <p:spPr>
           <a:xfrm>
-            <a:off x="4654296" y="2971800"/>
-            <a:ext cx="2880360" cy="2926080"/>
+            <a:off x="3694176" y="2971800"/>
+            <a:ext cx="2103120" cy="2926080"/>
           </a:xfrm>
           <a:prstGeom prst="rect">
             <a:avLst/>
@@ -12287,7 +12287,7 @@
               <a:buNone/>
             </a:pPr>
             <a:r>
-              <a:rPr lang="en-US" sz="960" dirty="0">
+              <a:rPr lang="en-US" sz="900" dirty="0">
                 <a:solidFill>
                   <a:srgbClr val="8E8E93"/>
                 </a:solidFill>
@@ -12295,14 +12295,14 @@
                 <a:ea typeface="Segoe UI" pitchFamily="34" charset="-122"/>
                 <a:cs typeface="Segoe UI" pitchFamily="34" charset="-120"/>
               </a:rPr>
-              <a:t>• Definición del modelo desacoplado en 4 capas de software.
+              <a:t>• Modelo Cliente-Servidor Multi-Capa (4 capas de software).
 </a:t>
             </a:r>
             <a:pPr indent="0" marL="0">
               <a:buNone/>
             </a:pPr>
             <a:r>
-              <a:rPr lang="en-US" sz="960" dirty="0">
+              <a:rPr lang="en-US" sz="900" dirty="0">
                 <a:solidFill>
                   <a:srgbClr val="8E8E93"/>
                 </a:solidFill>
@@ -12317,7 +12317,7 @@
               <a:buNone/>
             </a:pPr>
             <a:r>
-              <a:rPr lang="en-US" sz="960" dirty="0">
+              <a:rPr lang="en-US" sz="900" dirty="0">
                 <a:solidFill>
                   <a:srgbClr val="8E8E93"/>
                 </a:solidFill>
@@ -12325,14 +12325,14 @@
                 <a:ea typeface="Segoe UI" pitchFamily="34" charset="-122"/>
                 <a:cs typeface="Segoe UI" pitchFamily="34" charset="-120"/>
               </a:rPr>
-              <a:t>• Algoritmo de tarificación automatizada por minuto ($35 CLP/min).
+              <a:t>• Algoritmo de tarificación automatizada ($35 CLP/min).
 </a:t>
             </a:r>
             <a:pPr indent="0" marL="0">
               <a:buNone/>
             </a:pPr>
             <a:r>
-              <a:rPr lang="en-US" sz="960" dirty="0">
+              <a:rPr lang="en-US" sz="900" dirty="0">
                 <a:solidFill>
                   <a:srgbClr val="8E8E93"/>
                 </a:solidFill>
@@ -12340,14 +12340,14 @@
                 <a:ea typeface="Segoe UI" pitchFamily="34" charset="-122"/>
                 <a:cs typeface="Segoe UI" pitchFamily="34" charset="-120"/>
               </a:rPr>
-              <a:t>• Validaciones de formato chileno de patentes (BB-BB-11 / BBBB-11).
+              <a:t>• Validaciones de formato chileno de patentes vehiculares.
 </a:t>
             </a:r>
             <a:pPr indent="0" marL="0">
               <a:buNone/>
             </a:pPr>
             <a:r>
-              <a:rPr lang="en-US" sz="960" dirty="0">
+              <a:rPr lang="en-US" sz="900" dirty="0">
                 <a:solidFill>
                   <a:srgbClr val="8E8E93"/>
                 </a:solidFill>
@@ -12358,7 +12358,7 @@
               <a:t>• Trazabilidad y consistencia transaccional end-to-end.
 </a:t>
             </a:r>
-            <a:endParaRPr lang="en-US" sz="960" dirty="0"/>
+            <a:endParaRPr lang="en-US" sz="900" dirty="0"/>
           </a:p>
         </p:txBody>
       </p:sp>
@@ -12370,12 +12370,12 @@
         </p:nvSpPr>
         <p:spPr>
           <a:xfrm>
-            <a:off x="8028432" y="1783080"/>
-            <a:ext cx="3337560" cy="4343400"/>
+            <a:off x="6199632" y="1783080"/>
+            <a:ext cx="2468880" cy="4343400"/>
           </a:xfrm>
           <a:prstGeom prst="roundRect">
             <a:avLst>
-              <a:gd name="adj" fmla="val 4110"/>
+              <a:gd name="adj" fmla="val 5556"/>
             </a:avLst>
           </a:prstGeom>
           <a:solidFill>
@@ -12397,8 +12397,8 @@
         </p:nvSpPr>
         <p:spPr>
           <a:xfrm>
-            <a:off x="8257032" y="2011680"/>
-            <a:ext cx="2880360" cy="256032"/>
+            <a:off x="6382512" y="2011680"/>
+            <a:ext cx="2103120" cy="256032"/>
           </a:xfrm>
           <a:prstGeom prst="roundRect">
             <a:avLst>
@@ -12424,8 +12424,8 @@
         </p:nvSpPr>
         <p:spPr>
           <a:xfrm>
-            <a:off x="8257032" y="2011680"/>
-            <a:ext cx="2880360" cy="256032"/>
+            <a:off x="6382512" y="2011680"/>
+            <a:ext cx="2103120" cy="256032"/>
           </a:xfrm>
           <a:prstGeom prst="rect">
             <a:avLst/>
@@ -12463,8 +12463,8 @@
         </p:nvSpPr>
         <p:spPr>
           <a:xfrm>
-            <a:off x="8257032" y="2377440"/>
-            <a:ext cx="2880360" cy="502920"/>
+            <a:off x="6382512" y="2377440"/>
+            <a:ext cx="2103120" cy="502920"/>
           </a:xfrm>
           <a:prstGeom prst="rect">
             <a:avLst/>
@@ -12488,7 +12488,7 @@
                 <a:ea typeface="Segoe UI" pitchFamily="34" charset="-122"/>
                 <a:cs typeface="Segoe UI" pitchFamily="34" charset="-120"/>
               </a:rPr>
-              <a:t>Datos Cloud, DevOps &amp; Azure</a:t>
+              <a:t>Infraestructura Cloud &amp; DevOps Azure</a:t>
             </a:r>
             <a:endParaRPr lang="en-US" sz="1200" dirty="0"/>
           </a:p>
@@ -12502,8 +12502,8 @@
         </p:nvSpPr>
         <p:spPr>
           <a:xfrm>
-            <a:off x="8257032" y="2971800"/>
-            <a:ext cx="2880360" cy="2926080"/>
+            <a:off x="6382512" y="2971800"/>
+            <a:ext cx="2103120" cy="2926080"/>
           </a:xfrm>
           <a:prstGeom prst="rect">
             <a:avLst/>
@@ -12519,7 +12519,7 @@
               <a:buNone/>
             </a:pPr>
             <a:r>
-              <a:rPr lang="en-US" sz="960" dirty="0">
+              <a:rPr lang="en-US" sz="900" dirty="0">
                 <a:solidFill>
                   <a:srgbClr val="8E8E93"/>
                 </a:solidFill>
@@ -12527,14 +12527,14 @@
                 <a:ea typeface="Segoe UI" pitchFamily="34" charset="-122"/>
                 <a:cs typeface="Segoe UI" pitchFamily="34" charset="-120"/>
               </a:rPr>
-              <a:t>• Aprovisionamiento de VM en Microsoft Azure (Chile Central).
+              <a:t>• Aprovisionamiento de VM en Azure (Chile Central).
 </a:t>
             </a:r>
             <a:pPr indent="0" marL="0">
               <a:buNone/>
             </a:pPr>
             <a:r>
-              <a:rPr lang="en-US" sz="960" dirty="0">
+              <a:rPr lang="en-US" sz="900" dirty="0">
                 <a:solidFill>
                   <a:srgbClr val="8E8E93"/>
                 </a:solidFill>
@@ -12542,14 +12542,14 @@
                 <a:ea typeface="Segoe UI" pitchFamily="34" charset="-122"/>
                 <a:cs typeface="Segoe UI" pitchFamily="34" charset="-120"/>
               </a:rPr>
-              <a:t>• Endurecimiento de Windows Server 2022 con IIS 10.0.
+              <a:t>• Servidor Web IIS 10.0 sobre Windows Server 2022.
 </a:t>
             </a:r>
             <a:pPr indent="0" marL="0">
               <a:buNone/>
             </a:pPr>
             <a:r>
-              <a:rPr lang="en-US" sz="960" dirty="0">
+              <a:rPr lang="en-US" sz="900" dirty="0">
                 <a:solidFill>
                   <a:srgbClr val="8E8E93"/>
                 </a:solidFill>
@@ -12564,7 +12564,7 @@
               <a:buNone/>
             </a:pPr>
             <a:r>
-              <a:rPr lang="en-US" sz="960" dirty="0">
+              <a:rPr lang="en-US" sz="900" dirty="0">
                 <a:solidFill>
                   <a:srgbClr val="8E8E93"/>
                 </a:solidFill>
@@ -12579,7 +12579,7 @@
               <a:buNone/>
             </a:pPr>
             <a:r>
-              <a:rPr lang="en-US" sz="960" dirty="0">
+              <a:rPr lang="en-US" sz="900" dirty="0">
                 <a:solidFill>
                   <a:srgbClr val="8E8E93"/>
                 </a:solidFill>
@@ -12587,10 +12587,242 @@
                 <a:ea typeface="Segoe UI" pitchFamily="34" charset="-122"/>
                 <a:cs typeface="Segoe UI" pitchFamily="34" charset="-120"/>
               </a:rPr>
-              <a:t>• Integración y sincronización con Firebase Firestore (nubarda).
+              <a:t>• Despliegue estático de producción en C:\inetpub\wwwroot.
 </a:t>
             </a:r>
-            <a:endParaRPr lang="en-US" sz="960" dirty="0"/>
+            <a:endParaRPr lang="en-US" sz="900" dirty="0"/>
+          </a:p>
+        </p:txBody>
+      </p:sp>
+      <p:sp>
+        <p:nvSpPr>
+          <p:cNvPr id="23" name="Shape 21"/>
+          <p:cNvSpPr/>
+          <p:nvPr/>
+        </p:nvSpPr>
+        <p:spPr>
+          <a:xfrm>
+            <a:off x="8887968" y="1783080"/>
+            <a:ext cx="2468880" cy="4343400"/>
+          </a:xfrm>
+          <a:prstGeom prst="roundRect">
+            <a:avLst>
+              <a:gd name="adj" fmla="val 5556"/>
+            </a:avLst>
+          </a:prstGeom>
+          <a:solidFill>
+            <a:srgbClr val="14151B"/>
+          </a:solidFill>
+          <a:ln w="12700">
+            <a:solidFill>
+              <a:srgbClr val="242630"/>
+            </a:solidFill>
+            <a:prstDash val="solid"/>
+          </a:ln>
+        </p:spPr>
+      </p:sp>
+      <p:sp>
+        <p:nvSpPr>
+          <p:cNvPr id="24" name="Shape 22"/>
+          <p:cNvSpPr/>
+          <p:nvPr/>
+        </p:nvSpPr>
+        <p:spPr>
+          <a:xfrm>
+            <a:off x="9070848" y="2011680"/>
+            <a:ext cx="2103120" cy="256032"/>
+          </a:xfrm>
+          <a:prstGeom prst="roundRect">
+            <a:avLst>
+              <a:gd name="adj" fmla="val 50000"/>
+            </a:avLst>
+          </a:prstGeom>
+          <a:solidFill>
+            <a:srgbClr val="1C1E28"/>
+          </a:solidFill>
+          <a:ln w="10160">
+            <a:solidFill>
+              <a:srgbClr val="FF9F0A"/>
+            </a:solidFill>
+            <a:prstDash val="solid"/>
+          </a:ln>
+        </p:spPr>
+      </p:sp>
+      <p:sp>
+        <p:nvSpPr>
+          <p:cNvPr id="25" name="Text 23"/>
+          <p:cNvSpPr/>
+          <p:nvPr/>
+        </p:nvSpPr>
+        <p:spPr>
+          <a:xfrm>
+            <a:off x="9070848" y="2011680"/>
+            <a:ext cx="2103120" cy="256032"/>
+          </a:xfrm>
+          <a:prstGeom prst="rect">
+            <a:avLst/>
+          </a:prstGeom>
+          <a:noFill/>
+          <a:ln/>
+        </p:spPr>
+        <p:txBody>
+          <a:bodyPr wrap="square" rtlCol="0" anchor="ctr"/>
+          <a:lstStyle/>
+          <a:p>
+            <a:pPr algn="ctr" indent="0" marL="0">
+              <a:buNone/>
+            </a:pPr>
+            <a:r>
+              <a:rPr lang="en-US" sz="850" b="1" dirty="0">
+                <a:solidFill>
+                  <a:srgbClr val="FF9F0A"/>
+                </a:solidFill>
+                <a:latin typeface="Segoe UI" pitchFamily="34" charset="0"/>
+                <a:ea typeface="Segoe UI" pitchFamily="34" charset="-122"/>
+                <a:cs typeface="Segoe UI" pitchFamily="34" charset="-120"/>
+              </a:rPr>
+              <a:t>FELIPE LABARCA</a:t>
+            </a:r>
+            <a:endParaRPr lang="en-US" sz="850" dirty="0"/>
+          </a:p>
+        </p:txBody>
+      </p:sp>
+      <p:sp>
+        <p:nvSpPr>
+          <p:cNvPr id="26" name="Text 24"/>
+          <p:cNvSpPr/>
+          <p:nvPr/>
+        </p:nvSpPr>
+        <p:spPr>
+          <a:xfrm>
+            <a:off x="9070848" y="2377440"/>
+            <a:ext cx="2103120" cy="502920"/>
+          </a:xfrm>
+          <a:prstGeom prst="rect">
+            <a:avLst/>
+          </a:prstGeom>
+          <a:noFill/>
+          <a:ln/>
+        </p:spPr>
+        <p:txBody>
+          <a:bodyPr wrap="square" rtlCol="0" anchor="t"/>
+          <a:lstStyle/>
+          <a:p>
+            <a:pPr indent="0" marL="0">
+              <a:buNone/>
+            </a:pPr>
+            <a:r>
+              <a:rPr lang="en-US" sz="1200" b="1" dirty="0">
+                <a:solidFill>
+                  <a:srgbClr val="FFFFFF"/>
+                </a:solidFill>
+                <a:latin typeface="Segoe UI" pitchFamily="34" charset="0"/>
+                <a:ea typeface="Segoe UI" pitchFamily="34" charset="-122"/>
+                <a:cs typeface="Segoe UI" pitchFamily="34" charset="-120"/>
+              </a:rPr>
+              <a:t>Seguridad, JWT &amp; Persistencia Cloud</a:t>
+            </a:r>
+            <a:endParaRPr lang="en-US" sz="1200" dirty="0"/>
+          </a:p>
+        </p:txBody>
+      </p:sp>
+      <p:sp>
+        <p:nvSpPr>
+          <p:cNvPr id="27" name="Text 25"/>
+          <p:cNvSpPr/>
+          <p:nvPr/>
+        </p:nvSpPr>
+        <p:spPr>
+          <a:xfrm>
+            <a:off x="9070848" y="2971800"/>
+            <a:ext cx="2103120" cy="2926080"/>
+          </a:xfrm>
+          <a:prstGeom prst="rect">
+            <a:avLst/>
+          </a:prstGeom>
+          <a:noFill/>
+          <a:ln/>
+        </p:spPr>
+        <p:txBody>
+          <a:bodyPr wrap="square" rtlCol="0" anchor="t"/>
+          <a:lstStyle/>
+          <a:p>
+            <a:pPr indent="0" marL="0">
+              <a:buNone/>
+            </a:pPr>
+            <a:r>
+              <a:rPr lang="en-US" sz="900" dirty="0">
+                <a:solidFill>
+                  <a:srgbClr val="8E8E93"/>
+                </a:solidFill>
+                <a:latin typeface="Segoe UI" pitchFamily="34" charset="0"/>
+                <a:ea typeface="Segoe UI" pitchFamily="34" charset="-122"/>
+                <a:cs typeface="Segoe UI" pitchFamily="34" charset="-120"/>
+              </a:rPr>
+              <a:t>• Control de acceso por roles RBAC (Usuario vs Admin).
+</a:t>
+            </a:r>
+            <a:pPr indent="0" marL="0">
+              <a:buNone/>
+            </a:pPr>
+            <a:r>
+              <a:rPr lang="en-US" sz="900" dirty="0">
+                <a:solidFill>
+                  <a:srgbClr val="8E8E93"/>
+                </a:solidFill>
+                <a:latin typeface="Segoe UI" pitchFamily="34" charset="0"/>
+                <a:ea typeface="Segoe UI" pitchFamily="34" charset="-122"/>
+                <a:cs typeface="Segoe UI" pitchFamily="34" charset="-120"/>
+              </a:rPr>
+              <a:t>• Protección criptográfica con Tokens JWT (RFC 7519).
+</a:t>
+            </a:r>
+            <a:pPr indent="0" marL="0">
+              <a:buNone/>
+            </a:pPr>
+            <a:r>
+              <a:rPr lang="en-US" sz="900" dirty="0">
+                <a:solidFill>
+                  <a:srgbClr val="8E8E93"/>
+                </a:solidFill>
+                <a:latin typeface="Segoe UI" pitchFamily="34" charset="0"/>
+                <a:ea typeface="Segoe UI" pitchFamily="34" charset="-122"/>
+                <a:cs typeface="Segoe UI" pitchFamily="34" charset="-120"/>
+              </a:rPr>
+              <a:t>• Integración con base de datos NoSQL Firebase Firestore.
+</a:t>
+            </a:r>
+            <a:pPr indent="0" marL="0">
+              <a:buNone/>
+            </a:pPr>
+            <a:r>
+              <a:rPr lang="en-US" sz="900" dirty="0">
+                <a:solidFill>
+                  <a:srgbClr val="8E8E93"/>
+                </a:solidFill>
+                <a:latin typeface="Segoe UI" pitchFamily="34" charset="0"/>
+                <a:ea typeface="Segoe UI" pitchFamily="34" charset="-122"/>
+                <a:cs typeface="Segoe UI" pitchFamily="34" charset="-120"/>
+              </a:rPr>
+              <a:t>• Sincronización reactiva en tiempo real (onSnapshot).
+</a:t>
+            </a:r>
+            <a:pPr indent="0" marL="0">
+              <a:buNone/>
+            </a:pPr>
+            <a:r>
+              <a:rPr lang="en-US" sz="900" dirty="0">
+                <a:solidFill>
+                  <a:srgbClr val="8E8E93"/>
+                </a:solidFill>
+                <a:latin typeface="Segoe UI" pitchFamily="34" charset="0"/>
+                <a:ea typeface="Segoe UI" pitchFamily="34" charset="-122"/>
+                <a:cs typeface="Segoe UI" pitchFamily="34" charset="-120"/>
+              </a:rPr>
+              <a:t>• Registro de auditoría y trazabilidad de peticiones HTTP.
+</a:t>
+            </a:r>
+            <a:endParaRPr lang="en-US" sz="900" dirty="0"/>
           </a:p>
         </p:txBody>
       </p:sp>

</xml_diff>